<commit_message>
docs: add training curves to presentation (SegNT + Inpactor 2)
</commit_message>
<xml_diff>
--- a/docs/presentacion_final.pptx
+++ b/docs/presentacion_final.pptx
@@ -3234,7 +3234,7 @@
         </p:nvSpPr>
         <p:spPr>
           <a:xfrm>
-            <a:off x="640080" y="1371600"/>
+            <a:off x="457200" y="1371600"/>
             <a:ext cx="10972800" cy="5029200"/>
           </a:xfrm>
           <a:prstGeom prst="rect">
@@ -3390,8 +3390,8 @@
         </p:nvSpPr>
         <p:spPr>
           <a:xfrm>
-            <a:off x="640080" y="1371600"/>
-            <a:ext cx="10972800" cy="5029200"/>
+            <a:off x="457200" y="1371600"/>
+            <a:ext cx="4754880" cy="5029200"/>
           </a:xfrm>
           <a:prstGeom prst="rect">
             <a:avLst/>
@@ -3410,7 +3410,7 @@
               </a:spcBef>
             </a:pPr>
             <a:r>
-              <a:rPr sz="2000" b="1">
+              <a:rPr sz="1600" b="1">
                 <a:solidFill>
                   <a:srgbClr val="334155"/>
                 </a:solidFill>
@@ -3425,7 +3425,7 @@
               </a:spcBef>
             </a:pPr>
             <a:r>
-              <a:rPr sz="2000" b="1">
+              <a:rPr sz="1600" b="1">
                 <a:solidFill>
                   <a:srgbClr val="334155"/>
                 </a:solidFill>
@@ -3440,7 +3440,7 @@
               </a:spcBef>
             </a:pPr>
             <a:r>
-              <a:rPr sz="2000" b="1">
+              <a:rPr sz="1600" b="1">
                 <a:solidFill>
                   <a:srgbClr val="334155"/>
                 </a:solidFill>
@@ -3462,7 +3462,7 @@
               </a:spcBef>
             </a:pPr>
             <a:r>
-              <a:rPr sz="2000">
+              <a:rPr sz="1600">
                 <a:solidFill>
                   <a:srgbClr val="334155"/>
                 </a:solidFill>
@@ -3477,7 +3477,7 @@
               </a:spcBef>
             </a:pPr>
             <a:r>
-              <a:rPr sz="2000" b="1">
+              <a:rPr sz="1600" b="1">
                 <a:solidFill>
                   <a:srgbClr val="334155"/>
                 </a:solidFill>
@@ -3487,6 +3487,30 @@
           </a:p>
         </p:txBody>
       </p:sp>
+      <p:pic>
+        <p:nvPicPr>
+          <p:cNvPr id="4" name="Picture 3" descr="curve_segnt.png"/>
+          <p:cNvPicPr>
+            <a:picLocks noChangeAspect="1"/>
+          </p:cNvPicPr>
+          <p:nvPr/>
+        </p:nvPicPr>
+        <p:blipFill>
+          <a:blip r:embed="rId2"/>
+          <a:stretch>
+            <a:fillRect/>
+          </a:stretch>
+        </p:blipFill>
+        <p:spPr>
+          <a:xfrm>
+            <a:off x="5394960" y="1280160"/>
+            <a:ext cx="6583680" cy="2443044"/>
+          </a:xfrm>
+          <a:prstGeom prst="rect">
+            <a:avLst/>
+          </a:prstGeom>
+        </p:spPr>
+      </p:pic>
     </p:spTree>
   </p:cSld>
   <p:clrMapOvr>
@@ -3533,7 +3557,7 @@
                   <a:srgbClr val="0F172A"/>
                 </a:solidFill>
               </a:rPr>
-              <a:t>11 · Comparación SegNT antes/después</a:t>
+              <a:t>11 · Comparación · F1 val por época</a:t>
             </a:r>
           </a:p>
         </p:txBody>
@@ -3546,8 +3570,8 @@
         </p:nvSpPr>
         <p:spPr>
           <a:xfrm>
-            <a:off x="640080" y="1371600"/>
-            <a:ext cx="10972800" cy="5029200"/>
+            <a:off x="457200" y="1371600"/>
+            <a:ext cx="4754880" cy="5029200"/>
           </a:xfrm>
           <a:prstGeom prst="rect">
             <a:avLst/>
@@ -3566,105 +3590,107 @@
               </a:spcBef>
             </a:pPr>
             <a:r>
-              <a:rPr sz="2000" b="1">
-                <a:solidFill>
-                  <a:srgbClr val="334155"/>
-                </a:solidFill>
-              </a:rPr>
-              <a:t>•  Antes (InpactorDB solo plantas):    F1 val = 0.14</a:t>
-            </a:r>
-          </a:p>
-          <a:p>
-            <a:pPr>
-              <a:spcBef>
-                <a:spcPts val="800"/>
-              </a:spcBef>
-            </a:pPr>
-            <a:r>
-              <a:rPr sz="2000" b="1">
-                <a:solidFill>
-                  <a:srgbClr val="334155"/>
-                </a:solidFill>
-              </a:rPr>
-              <a:t>•  Ahora (PanTEon cross-kingdom):      F1 val = 0.886</a:t>
-            </a:r>
-          </a:p>
-          <a:p>
-            <a:pPr>
-              <a:spcBef>
-                <a:spcPts val="800"/>
-              </a:spcBef>
-            </a:pPr>
-          </a:p>
-          <a:p>
-            <a:pPr>
-              <a:spcBef>
-                <a:spcPts val="800"/>
-              </a:spcBef>
-            </a:pPr>
-            <a:r>
-              <a:rPr sz="2000" b="1">
-                <a:solidFill>
-                  <a:srgbClr val="334155"/>
-                </a:solidFill>
-              </a:rPr>
-              <a:t>•  Mejora: × 6.3</a:t>
-            </a:r>
-          </a:p>
-          <a:p>
-            <a:pPr>
-              <a:spcBef>
-                <a:spcPts val="800"/>
-              </a:spcBef>
-            </a:pPr>
-          </a:p>
-          <a:p>
-            <a:pPr>
-              <a:spcBef>
-                <a:spcPts val="800"/>
-              </a:spcBef>
-            </a:pPr>
-            <a:r>
-              <a:rPr sz="2000">
-                <a:solidFill>
-                  <a:srgbClr val="334155"/>
-                </a:solidFill>
-              </a:rPr>
-              <a:t>•  El salto no fue por cambiar la red — fue por:</a:t>
-            </a:r>
-          </a:p>
-          <a:p>
-            <a:pPr>
-              <a:spcBef>
-                <a:spcPts val="800"/>
-              </a:spcBef>
-            </a:pPr>
-            <a:r>
-              <a:rPr sz="2000">
-                <a:solidFill>
-                  <a:srgbClr val="334155"/>
-                </a:solidFill>
-              </a:rPr>
-              <a:t>•    1) Más datos cross-kingdom</a:t>
-            </a:r>
-          </a:p>
-          <a:p>
-            <a:pPr>
-              <a:spcBef>
-                <a:spcPts val="800"/>
-              </a:spcBef>
-            </a:pPr>
-            <a:r>
-              <a:rPr sz="2000">
-                <a:solidFill>
-                  <a:srgbClr val="334155"/>
-                </a:solidFill>
-              </a:rPr>
-              <a:t>•    2) Congelar el encoder</a:t>
-            </a:r>
-          </a:p>
-        </p:txBody>
-      </p:sp>
+              <a:rPr sz="1600" b="1">
+                <a:solidFill>
+                  <a:srgbClr val="334155"/>
+                </a:solidFill>
+              </a:rPr>
+              <a:t>•  SegNT llegó a F1=0.886</a:t>
+            </a:r>
+          </a:p>
+          <a:p>
+            <a:pPr>
+              <a:spcBef>
+                <a:spcPts val="800"/>
+              </a:spcBef>
+            </a:pPr>
+            <a:r>
+              <a:rPr sz="1600" b="1">
+                <a:solidFill>
+                  <a:srgbClr val="334155"/>
+                </a:solidFill>
+              </a:rPr>
+              <a:t>•  Inpactor 2 Class llegó a F1=0.81</a:t>
+            </a:r>
+          </a:p>
+          <a:p>
+            <a:pPr>
+              <a:spcBef>
+                <a:spcPts val="800"/>
+              </a:spcBef>
+            </a:pPr>
+            <a:r>
+              <a:rPr sz="1600" b="1">
+                <a:solidFill>
+                  <a:srgbClr val="334155"/>
+                </a:solidFill>
+              </a:rPr>
+              <a:t>•  Inpactor 2 Detect llegó a F1=0.39</a:t>
+            </a:r>
+          </a:p>
+          <a:p>
+            <a:pPr>
+              <a:spcBef>
+                <a:spcPts val="800"/>
+              </a:spcBef>
+            </a:pPr>
+          </a:p>
+          <a:p>
+            <a:pPr>
+              <a:spcBef>
+                <a:spcPts val="800"/>
+              </a:spcBef>
+            </a:pPr>
+            <a:r>
+              <a:rPr sz="1600" b="1">
+                <a:solidFill>
+                  <a:srgbClr val="334155"/>
+                </a:solidFill>
+              </a:rPr>
+              <a:t>•  SegNT (versión anterior sobre InpactorDB): F1=0.14</a:t>
+            </a:r>
+          </a:p>
+          <a:p>
+            <a:pPr>
+              <a:spcBef>
+                <a:spcPts val="800"/>
+              </a:spcBef>
+            </a:pPr>
+            <a:r>
+              <a:rPr sz="1600" b="1">
+                <a:solidFill>
+                  <a:srgbClr val="334155"/>
+                </a:solidFill>
+              </a:rPr>
+              <a:t>•  Mejora × 6.3 con PanTEon + encoder congelado.</a:t>
+            </a:r>
+          </a:p>
+        </p:txBody>
+      </p:sp>
+      <p:pic>
+        <p:nvPicPr>
+          <p:cNvPr id="4" name="Picture 3" descr="curve_comparativa.png"/>
+          <p:cNvPicPr>
+            <a:picLocks noChangeAspect="1"/>
+          </p:cNvPicPr>
+          <p:nvPr/>
+        </p:nvPicPr>
+        <p:blipFill>
+          <a:blip r:embed="rId2"/>
+          <a:stretch>
+            <a:fillRect/>
+          </a:stretch>
+        </p:blipFill>
+        <p:spPr>
+          <a:xfrm>
+            <a:off x="5394960" y="1280160"/>
+            <a:ext cx="6583680" cy="3363180"/>
+          </a:xfrm>
+          <a:prstGeom prst="rect">
+            <a:avLst/>
+          </a:prstGeom>
+        </p:spPr>
+      </p:pic>
     </p:spTree>
   </p:cSld>
   <p:clrMapOvr>
@@ -3724,7 +3750,7 @@
         </p:nvSpPr>
         <p:spPr>
           <a:xfrm>
-            <a:off x="640080" y="1371600"/>
+            <a:off x="457200" y="1371600"/>
             <a:ext cx="10972800" cy="5029200"/>
           </a:xfrm>
           <a:prstGeom prst="rect">
@@ -3917,7 +3943,7 @@
         </p:nvSpPr>
         <p:spPr>
           <a:xfrm>
-            <a:off x="640080" y="1371600"/>
+            <a:off x="457200" y="1371600"/>
             <a:ext cx="10972800" cy="5029200"/>
           </a:xfrm>
           <a:prstGeom prst="rect">
@@ -4110,7 +4136,7 @@
         </p:nvSpPr>
         <p:spPr>
           <a:xfrm>
-            <a:off x="640080" y="1371600"/>
+            <a:off x="457200" y="1371600"/>
             <a:ext cx="10972800" cy="5029200"/>
           </a:xfrm>
           <a:prstGeom prst="rect">
@@ -4288,7 +4314,7 @@
         </p:nvSpPr>
         <p:spPr>
           <a:xfrm>
-            <a:off x="640080" y="1371600"/>
+            <a:off x="457200" y="1371600"/>
             <a:ext cx="10972800" cy="5029200"/>
           </a:xfrm>
           <a:prstGeom prst="rect">
@@ -4459,7 +4485,7 @@
         </p:nvSpPr>
         <p:spPr>
           <a:xfrm>
-            <a:off x="640080" y="1371600"/>
+            <a:off x="457200" y="1371600"/>
             <a:ext cx="10972800" cy="5029200"/>
           </a:xfrm>
           <a:prstGeom prst="rect">
@@ -4629,7 +4655,7 @@
         </p:nvSpPr>
         <p:spPr>
           <a:xfrm>
-            <a:off x="640080" y="1371600"/>
+            <a:off x="457200" y="1371600"/>
             <a:ext cx="10972800" cy="5029200"/>
           </a:xfrm>
           <a:prstGeom prst="rect">
@@ -4806,7 +4832,7 @@
         </p:nvSpPr>
         <p:spPr>
           <a:xfrm>
-            <a:off x="640080" y="1371600"/>
+            <a:off x="457200" y="1371600"/>
             <a:ext cx="10972800" cy="5029200"/>
           </a:xfrm>
           <a:prstGeom prst="rect">
@@ -4983,7 +5009,7 @@
         </p:nvSpPr>
         <p:spPr>
           <a:xfrm>
-            <a:off x="640080" y="1371600"/>
+            <a:off x="457200" y="1371600"/>
             <a:ext cx="10972800" cy="5029200"/>
           </a:xfrm>
           <a:prstGeom prst="rect">
@@ -5124,7 +5150,7 @@
         </p:nvSpPr>
         <p:spPr>
           <a:xfrm>
-            <a:off x="640080" y="1371600"/>
+            <a:off x="457200" y="1371600"/>
             <a:ext cx="10972800" cy="5029200"/>
           </a:xfrm>
           <a:prstGeom prst="rect">
@@ -5301,7 +5327,7 @@
         </p:nvSpPr>
         <p:spPr>
           <a:xfrm>
-            <a:off x="640080" y="1371600"/>
+            <a:off x="457200" y="1371600"/>
             <a:ext cx="10972800" cy="5029200"/>
           </a:xfrm>
           <a:prstGeom prst="rect">
@@ -5450,7 +5476,7 @@
         </p:nvSpPr>
         <p:spPr>
           <a:xfrm>
-            <a:off x="640080" y="1371600"/>
+            <a:off x="457200" y="1371600"/>
             <a:ext cx="10972800" cy="5029200"/>
           </a:xfrm>
           <a:prstGeom prst="rect">
@@ -5606,7 +5632,7 @@
         </p:nvSpPr>
         <p:spPr>
           <a:xfrm>
-            <a:off x="640080" y="1371600"/>
+            <a:off x="457200" y="1371600"/>
             <a:ext cx="10972800" cy="5029200"/>
           </a:xfrm>
           <a:prstGeom prst="rect">
@@ -5769,7 +5795,7 @@
         </p:nvSpPr>
         <p:spPr>
           <a:xfrm>
-            <a:off x="640080" y="1371600"/>
+            <a:off x="457200" y="1371600"/>
             <a:ext cx="10972800" cy="5029200"/>
           </a:xfrm>
           <a:prstGeom prst="rect">
@@ -5925,7 +5951,7 @@
         </p:nvSpPr>
         <p:spPr>
           <a:xfrm>
-            <a:off x="640080" y="1371600"/>
+            <a:off x="457200" y="1371600"/>
             <a:ext cx="10972800" cy="5029200"/>
           </a:xfrm>
           <a:prstGeom prst="rect">
@@ -6081,7 +6107,7 @@
         </p:nvSpPr>
         <p:spPr>
           <a:xfrm>
-            <a:off x="640080" y="1371600"/>
+            <a:off x="457200" y="1371600"/>
             <a:ext cx="10972800" cy="5029200"/>
           </a:xfrm>
           <a:prstGeom prst="rect">
@@ -6237,8 +6263,8 @@
         </p:nvSpPr>
         <p:spPr>
           <a:xfrm>
-            <a:off x="640080" y="1371600"/>
-            <a:ext cx="10972800" cy="5029200"/>
+            <a:off x="457200" y="1371600"/>
+            <a:ext cx="4754880" cy="5029200"/>
           </a:xfrm>
           <a:prstGeom prst="rect">
             <a:avLst/>
@@ -6257,7 +6283,7 @@
               </a:spcBef>
             </a:pPr>
             <a:r>
-              <a:rPr sz="2000" b="1">
+              <a:rPr sz="1600" b="1">
                 <a:solidFill>
                   <a:srgbClr val="334155"/>
                 </a:solidFill>
@@ -6272,7 +6298,7 @@
               </a:spcBef>
             </a:pPr>
             <a:r>
-              <a:rPr sz="2000" b="1">
+              <a:rPr sz="1600" b="1">
                 <a:solidFill>
                   <a:srgbClr val="334155"/>
                 </a:solidFill>
@@ -6294,7 +6320,7 @@
               </a:spcBef>
             </a:pPr>
             <a:r>
-              <a:rPr sz="2000">
+              <a:rPr sz="1600">
                 <a:solidFill>
                   <a:srgbClr val="334155"/>
                 </a:solidFill>
@@ -6309,7 +6335,7 @@
               </a:spcBef>
             </a:pPr>
             <a:r>
-              <a:rPr sz="2000">
+              <a:rPr sz="1600">
                 <a:solidFill>
                   <a:srgbClr val="334155"/>
                 </a:solidFill>
@@ -6319,6 +6345,30 @@
           </a:p>
         </p:txBody>
       </p:sp>
+      <p:pic>
+        <p:nvPicPr>
+          <p:cNvPr id="4" name="Picture 3" descr="curve_inpactor2.png"/>
+          <p:cNvPicPr>
+            <a:picLocks noChangeAspect="1"/>
+          </p:cNvPicPr>
+          <p:nvPr/>
+        </p:nvPicPr>
+        <p:blipFill>
+          <a:blip r:embed="rId2"/>
+          <a:stretch>
+            <a:fillRect/>
+          </a:stretch>
+        </p:blipFill>
+        <p:spPr>
+          <a:xfrm>
+            <a:off x="5394960" y="1280160"/>
+            <a:ext cx="6583680" cy="3808572"/>
+          </a:xfrm>
+          <a:prstGeom prst="rect">
+            <a:avLst/>
+          </a:prstGeom>
+        </p:spPr>
+      </p:pic>
     </p:spTree>
   </p:cSld>
   <p:clrMapOvr>

</xml_diff>

<commit_message>
docs: add piña results to presentation (463 anot, 1.11%)
</commit_message>
<xml_diff>
--- a/docs/presentacion_final.pptx
+++ b/docs/presentacion_final.pptx
@@ -25,6 +25,7 @@
     <p:sldId id="273" r:id="rId24"/>
     <p:sldId id="274" r:id="rId25"/>
     <p:sldId id="275" r:id="rId26"/>
+    <p:sldId id="276" r:id="rId27"/>
   </p:sldIdLst>
   <p:sldSz cx="12191695" cy="6858000" type="screen4x3"/>
   <p:notesSz cx="6858000" cy="9144000"/>
@@ -4123,7 +4124,7 @@
                   <a:srgbClr val="0F172A"/>
                 </a:solidFill>
               </a:rPr>
-              <a:t>14 · Proporciones entre especies · biología correcta</a:t>
+              <a:t>14 · Resultado Inpactor 2 · Piña (Ananas comosus)</a:t>
             </a:r>
           </a:p>
         </p:txBody>
@@ -4161,7 +4162,29 @@
                   <a:srgbClr val="334155"/>
                 </a:solidFill>
               </a:rPr>
-              <a:t>•  Anot./Mb:</a:t>
+              <a:t>•  Genoma: 382 Mb · 3 129 scaffolds</a:t>
+            </a:r>
+          </a:p>
+          <a:p>
+            <a:pPr>
+              <a:spcBef>
+                <a:spcPts val="800"/>
+              </a:spcBef>
+            </a:pPr>
+          </a:p>
+          <a:p>
+            <a:pPr>
+              <a:spcBef>
+                <a:spcPts val="800"/>
+              </a:spcBef>
+            </a:pPr>
+            <a:r>
+              <a:rPr sz="2000">
+                <a:solidFill>
+                  <a:srgbClr val="334155"/>
+                </a:solidFill>
+              </a:rPr>
+              <a:t>•  Total anotaciones:  463</a:t>
             </a:r>
           </a:p>
           <a:p>
@@ -4176,7 +4199,7 @@
                   <a:srgbClr val="334155"/>
                 </a:solidFill>
               </a:rPr>
-              <a:t>•    Arabidopsis  →  0.49  (1.0×)</a:t>
+              <a:t>•    RLG/GYPSY  →  376 (81%)</a:t>
             </a:r>
           </a:p>
           <a:p>
@@ -4191,30 +4214,15 @@
                   <a:srgbClr val="334155"/>
                 </a:solidFill>
               </a:rPr>
-              <a:t>•    Arroz        →  2.25  (4.6×)</a:t>
-            </a:r>
-          </a:p>
-          <a:p>
-            <a:pPr>
-              <a:spcBef>
-                <a:spcPts val="800"/>
-              </a:spcBef>
-            </a:pPr>
-          </a:p>
-          <a:p>
-            <a:pPr>
-              <a:spcBef>
-                <a:spcPts val="800"/>
-              </a:spcBef>
-            </a:pPr>
-            <a:r>
-              <a:rPr sz="2000" b="1">
-                <a:solidFill>
-                  <a:srgbClr val="334155"/>
-                </a:solidFill>
-              </a:rPr>
-              <a:t>•  Arroz tiene 4.6× más LTR-RTs por Mb que Arabidopsis.</a:t>
-            </a:r>
+              <a:t>•    RLC/COPIA  →   87 (19%)</a:t>
+            </a:r>
+          </a:p>
+          <a:p>
+            <a:pPr>
+              <a:spcBef>
+                <a:spcPts val="800"/>
+              </a:spcBef>
+            </a:pPr>
           </a:p>
           <a:p>
             <a:pPr>
@@ -4228,29 +4236,7 @@
                   <a:srgbClr val="334155"/>
                 </a:solidFill>
               </a:rPr>
-              <a:t>•  Coincide exactamente con la literatura.</a:t>
-            </a:r>
-          </a:p>
-          <a:p>
-            <a:pPr>
-              <a:spcBef>
-                <a:spcPts val="800"/>
-              </a:spcBef>
-            </a:pPr>
-          </a:p>
-          <a:p>
-            <a:pPr>
-              <a:spcBef>
-                <a:spcPts val="800"/>
-              </a:spcBef>
-            </a:pPr>
-            <a:r>
-              <a:rPr sz="2000">
-                <a:solidFill>
-                  <a:srgbClr val="334155"/>
-                </a:solidFill>
-              </a:rPr>
-              <a:t>•  El modelo captura correctamente las diferencias entre especies.</a:t>
+              <a:t>•  % del genoma: 1.11%  ·  Tiempo: 1 h 51 min</a:t>
             </a:r>
           </a:p>
         </p:txBody>
@@ -4301,7 +4287,7 @@
                   <a:srgbClr val="0F172A"/>
                 </a:solidFill>
               </a:rPr>
-              <a:t>15 · Tabla resumen ejecutivo</a:t>
+              <a:t>15 · Proporciones entre especies · biología correcta</a:t>
             </a:r>
           </a:p>
         </p:txBody>
@@ -4334,13 +4320,80 @@
               </a:spcBef>
             </a:pPr>
             <a:r>
+              <a:rPr sz="2000">
+                <a:solidFill>
+                  <a:srgbClr val="334155"/>
+                </a:solidFill>
+              </a:rPr>
+              <a:t>•  Especie      | Anot./Mb | Ratio vs Arabidopsis</a:t>
+            </a:r>
+          </a:p>
+          <a:p>
+            <a:pPr>
+              <a:spcBef>
+                <a:spcPts val="800"/>
+              </a:spcBef>
+            </a:pPr>
+            <a:r>
+              <a:rPr sz="2000">
+                <a:solidFill>
+                  <a:srgbClr val="334155"/>
+                </a:solidFill>
+              </a:rPr>
+              <a:t>•  -------      | -------- | -------------------</a:t>
+            </a:r>
+          </a:p>
+          <a:p>
+            <a:pPr>
+              <a:spcBef>
+                <a:spcPts val="800"/>
+              </a:spcBef>
+            </a:pPr>
+            <a:r>
               <a:rPr sz="2000" b="1">
                 <a:solidFill>
                   <a:srgbClr val="334155"/>
                 </a:solidFill>
               </a:rPr>
-              <a:t>•  Modelo                          | val_F1 | Arabidopsis</a:t>
-            </a:r>
+              <a:t>•  Arabidopsis  |   0.49   |  1.0×</a:t>
+            </a:r>
+          </a:p>
+          <a:p>
+            <a:pPr>
+              <a:spcBef>
+                <a:spcPts val="800"/>
+              </a:spcBef>
+            </a:pPr>
+            <a:r>
+              <a:rPr sz="2000" b="1">
+                <a:solidFill>
+                  <a:srgbClr val="334155"/>
+                </a:solidFill>
+              </a:rPr>
+              <a:t>•  Arroz        |   2.25   |  4.6×</a:t>
+            </a:r>
+          </a:p>
+          <a:p>
+            <a:pPr>
+              <a:spcBef>
+                <a:spcPts val="800"/>
+              </a:spcBef>
+            </a:pPr>
+            <a:r>
+              <a:rPr sz="2000" b="1">
+                <a:solidFill>
+                  <a:srgbClr val="334155"/>
+                </a:solidFill>
+              </a:rPr>
+              <a:t>•  Piña         |   1.21   |  2.5×</a:t>
+            </a:r>
+          </a:p>
+          <a:p>
+            <a:pPr>
+              <a:spcBef>
+                <a:spcPts val="800"/>
+              </a:spcBef>
+            </a:pPr>
           </a:p>
           <a:p>
             <a:pPr>
@@ -4354,7 +4407,7 @@
                   <a:srgbClr val="334155"/>
                 </a:solidFill>
               </a:rPr>
-              <a:t>•  -------                         | ------ | -----------</a:t>
+              <a:t>•  El ratio entre especies coincide con la literatura.</a:t>
             </a:r>
           </a:p>
           <a:p>
@@ -4369,59 +4422,7 @@
                   <a:srgbClr val="334155"/>
                 </a:solidFill>
               </a:rPr>
-              <a:t>•  Inpactor 2 original             |    —   | 109 anot</a:t>
-            </a:r>
-          </a:p>
-          <a:p>
-            <a:pPr>
-              <a:spcBef>
-                <a:spcPts val="800"/>
-              </a:spcBef>
-            </a:pPr>
-            <a:r>
-              <a:rPr sz="2000">
-                <a:solidFill>
-                  <a:srgbClr val="334155"/>
-                </a:solidFill>
-              </a:rPr>
-              <a:t>•  Inpactor 2 re-entrenado         |  0.39  |  58 anot</a:t>
-            </a:r>
-          </a:p>
-          <a:p>
-            <a:pPr>
-              <a:spcBef>
-                <a:spcPts val="800"/>
-              </a:spcBef>
-            </a:pPr>
-            <a:r>
-              <a:rPr sz="2000">
-                <a:solidFill>
-                  <a:srgbClr val="334155"/>
-                </a:solidFill>
-              </a:rPr>
-              <a:t>•  SegNT (val cross-kingdom)       |  0.886 | (perdido)</a:t>
-            </a:r>
-          </a:p>
-          <a:p>
-            <a:pPr>
-              <a:spcBef>
-                <a:spcPts val="800"/>
-              </a:spcBef>
-            </a:pPr>
-          </a:p>
-          <a:p>
-            <a:pPr>
-              <a:spcBef>
-                <a:spcPts val="800"/>
-              </a:spcBef>
-            </a:pPr>
-            <a:r>
-              <a:rPr sz="2000">
-                <a:solidFill>
-                  <a:srgbClr val="334155"/>
-                </a:solidFill>
-              </a:rPr>
-              <a:t>•  Piña y maíz: pendientes en Inpactor 2 re-entrenado.</a:t>
+              <a:t>•  El modelo captura correctamente las diferencias biológicas.</a:t>
             </a:r>
           </a:p>
         </p:txBody>
@@ -4472,7 +4473,7 @@
                   <a:srgbClr val="0F172A"/>
                 </a:solidFill>
               </a:rPr>
-              <a:t>16 · Limitaciones honestas</a:t>
+              <a:t>15 · Tabla resumen ejecutivo</a:t>
             </a:r>
           </a:p>
         </p:txBody>
@@ -4505,35 +4506,28 @@
               </a:spcBef>
             </a:pPr>
             <a:r>
+              <a:rPr sz="2000" b="1">
+                <a:solidFill>
+                  <a:srgbClr val="334155"/>
+                </a:solidFill>
+              </a:rPr>
+              <a:t>•  Modelo                          | val_F1 | Arabidopsis</a:t>
+            </a:r>
+          </a:p>
+          <a:p>
+            <a:pPr>
+              <a:spcBef>
+                <a:spcPts val="800"/>
+              </a:spcBef>
+            </a:pPr>
+            <a:r>
               <a:rPr sz="2000">
                 <a:solidFill>
                   <a:srgbClr val="334155"/>
                 </a:solidFill>
               </a:rPr>
-              <a:t>•  SegNT: modelo entrenado se perdió al morir Colab</a:t>
-            </a:r>
-          </a:p>
-          <a:p>
-            <a:pPr>
-              <a:spcBef>
-                <a:spcPts val="800"/>
-              </a:spcBef>
-            </a:pPr>
-            <a:r>
-              <a:rPr sz="2000" b="1">
-                <a:solidFill>
-                  <a:srgbClr val="334155"/>
-                </a:solidFill>
-              </a:rPr>
-              <a:t>•    → métricas documentadas pero no aplicable sin re-entrenar</a:t>
-            </a:r>
-          </a:p>
-          <a:p>
-            <a:pPr>
-              <a:spcBef>
-                <a:spcPts val="800"/>
-              </a:spcBef>
-            </a:pPr>
+              <a:t>•  -------                         | ------ | -----------</a:t>
+            </a:r>
           </a:p>
           <a:p>
             <a:pPr>
@@ -4547,15 +4541,8 @@
                   <a:srgbClr val="334155"/>
                 </a:solidFill>
               </a:rPr>
-              <a:t>•  Piloto reducido: 9 307 ventanas vs 70 000 del paper original</a:t>
-            </a:r>
-          </a:p>
-          <a:p>
-            <a:pPr>
-              <a:spcBef>
-                <a:spcPts val="800"/>
-              </a:spcBef>
-            </a:pPr>
+              <a:t>•  Inpactor 2 original             |    —   | 109 anot</a:t>
+            </a:r>
           </a:p>
           <a:p>
             <a:pPr>
@@ -4569,15 +4556,8 @@
                   <a:srgbClr val="334155"/>
                 </a:solidFill>
               </a:rPr>
-              <a:t>•  Inpactor 2 solo detecta LTR-RTs íntegros, no degradados</a:t>
-            </a:r>
-          </a:p>
-          <a:p>
-            <a:pPr>
-              <a:spcBef>
-                <a:spcPts val="800"/>
-              </a:spcBef>
-            </a:pPr>
+              <a:t>•  Inpactor 2 re-entrenado         |  0.39  |  58 anot</a:t>
+            </a:r>
           </a:p>
           <a:p>
             <a:pPr>
@@ -4591,7 +4571,29 @@
                   <a:srgbClr val="334155"/>
                 </a:solidFill>
               </a:rPr>
-              <a:t>•  Filter no se re-entrenó (falta etiqueta de intactness)</a:t>
+              <a:t>•  SegNT (val cross-kingdom)       |  0.886 | (perdido)</a:t>
+            </a:r>
+          </a:p>
+          <a:p>
+            <a:pPr>
+              <a:spcBef>
+                <a:spcPts val="800"/>
+              </a:spcBef>
+            </a:pPr>
+          </a:p>
+          <a:p>
+            <a:pPr>
+              <a:spcBef>
+                <a:spcPts val="800"/>
+              </a:spcBef>
+            </a:pPr>
+            <a:r>
+              <a:rPr sz="2000">
+                <a:solidFill>
+                  <a:srgbClr val="334155"/>
+                </a:solidFill>
+              </a:rPr>
+              <a:t>•  Piña y maíz: pendientes en Inpactor 2 re-entrenado.</a:t>
             </a:r>
           </a:p>
         </p:txBody>
@@ -4642,7 +4644,7 @@
                   <a:srgbClr val="0F172A"/>
                 </a:solidFill>
               </a:rPr>
-              <a:t>17 · Contribuciones del trabajo</a:t>
+              <a:t>16 · Limitaciones honestas</a:t>
             </a:r>
           </a:p>
         </p:txBody>
@@ -4675,12 +4677,27 @@
               </a:spcBef>
             </a:pPr>
             <a:r>
+              <a:rPr sz="2000">
+                <a:solidFill>
+                  <a:srgbClr val="334155"/>
+                </a:solidFill>
+              </a:rPr>
+              <a:t>•  SegNT: modelo entrenado se perdió al morir Colab</a:t>
+            </a:r>
+          </a:p>
+          <a:p>
+            <a:pPr>
+              <a:spcBef>
+                <a:spcPts val="800"/>
+              </a:spcBef>
+            </a:pPr>
+            <a:r>
               <a:rPr sz="2000" b="1">
                 <a:solidFill>
                   <a:srgbClr val="334155"/>
                 </a:solidFill>
               </a:rPr>
-              <a:t>•  Pipeline reproducible cross-kingdom PanTEon → 2 modelos</a:t>
+              <a:t>•    → métricas documentadas pero no aplicable sin re-entrenar</a:t>
             </a:r>
           </a:p>
           <a:p>
@@ -4702,29 +4719,7 @@
                   <a:srgbClr val="334155"/>
                 </a:solidFill>
               </a:rPr>
-              <a:t>•  Primer benchmark de Inpactor 2 con datos animales/hongos</a:t>
-            </a:r>
-          </a:p>
-          <a:p>
-            <a:pPr>
-              <a:spcBef>
-                <a:spcPts val="800"/>
-              </a:spcBef>
-            </a:pPr>
-          </a:p>
-          <a:p>
-            <a:pPr>
-              <a:spcBef>
-                <a:spcPts val="800"/>
-              </a:spcBef>
-            </a:pPr>
-            <a:r>
-              <a:rPr sz="2000" b="1">
-                <a:solidFill>
-                  <a:srgbClr val="334155"/>
-                </a:solidFill>
-              </a:rPr>
-              <a:t>•  Prueba de concepto SegNT + encoder congelado (F1=0.886)</a:t>
+              <a:t>•  Piloto reducido: 9 307 ventanas vs 70 000 del paper original</a:t>
             </a:r>
           </a:p>
           <a:p>
@@ -4746,7 +4741,7 @@
                   <a:srgbClr val="334155"/>
                 </a:solidFill>
               </a:rPr>
-              <a:t>•  Formato común para comparar arquitecturas heterogéneas</a:t>
+              <a:t>•  Inpactor 2 solo detecta LTR-RTs íntegros, no degradados</a:t>
             </a:r>
           </a:p>
           <a:p>
@@ -4768,7 +4763,7 @@
                   <a:srgbClr val="334155"/>
                 </a:solidFill>
               </a:rPr>
-              <a:t>•  Todo en GitHub: git clone + notebook = reproducible</a:t>
+              <a:t>•  Filter no se re-entrenó (falta etiqueta de intactness)</a:t>
             </a:r>
           </a:p>
         </p:txBody>
@@ -4819,7 +4814,7 @@
                   <a:srgbClr val="0F172A"/>
                 </a:solidFill>
               </a:rPr>
-              <a:t>18 · Próximos pasos</a:t>
+              <a:t>17 · Contribuciones del trabajo</a:t>
             </a:r>
           </a:p>
         </p:txBody>
@@ -4852,12 +4847,34 @@
               </a:spcBef>
             </a:pPr>
             <a:r>
+              <a:rPr sz="2000" b="1">
+                <a:solidFill>
+                  <a:srgbClr val="334155"/>
+                </a:solidFill>
+              </a:rPr>
+              <a:t>•  Pipeline reproducible cross-kingdom PanTEon → 2 modelos</a:t>
+            </a:r>
+          </a:p>
+          <a:p>
+            <a:pPr>
+              <a:spcBef>
+                <a:spcPts val="800"/>
+              </a:spcBef>
+            </a:pPr>
+          </a:p>
+          <a:p>
+            <a:pPr>
+              <a:spcBef>
+                <a:spcPts val="800"/>
+              </a:spcBef>
+            </a:pPr>
+            <a:r>
               <a:rPr sz="2000">
                 <a:solidFill>
                   <a:srgbClr val="334155"/>
                 </a:solidFill>
               </a:rPr>
-              <a:t>•  Re-entrenar SegNT con guardado a Drive cada época</a:t>
+              <a:t>•  Primer benchmark de Inpactor 2 con datos animales/hongos</a:t>
             </a:r>
           </a:p>
           <a:p>
@@ -4879,7 +4896,7 @@
                   <a:srgbClr val="334155"/>
                 </a:solidFill>
               </a:rPr>
-              <a:t>•  Escalar dataset piloto: 50 000 → 200 000 ventanas</a:t>
+              <a:t>•  Prueba de concepto SegNT + encoder congelado (F1=0.886)</a:t>
             </a:r>
           </a:p>
           <a:p>
@@ -4901,7 +4918,7 @@
                   <a:srgbClr val="334155"/>
                 </a:solidFill>
               </a:rPr>
-              <a:t>•  Re-entrenar Filter con etiquetas de intactness</a:t>
+              <a:t>•  Formato común para comparar arquitecturas heterogéneas</a:t>
             </a:r>
           </a:p>
           <a:p>
@@ -4923,29 +4940,7 @@
                   <a:srgbClr val="334155"/>
                 </a:solidFill>
               </a:rPr>
-              <a:t>•  Evaluar sobre maíz (2 Gb) y trigo (14 Gb)</a:t>
-            </a:r>
-          </a:p>
-          <a:p>
-            <a:pPr>
-              <a:spcBef>
-                <a:spcPts val="800"/>
-              </a:spcBef>
-            </a:pPr>
-          </a:p>
-          <a:p>
-            <a:pPr>
-              <a:spcBef>
-                <a:spcPts val="800"/>
-              </a:spcBef>
-            </a:pPr>
-            <a:r>
-              <a:rPr sz="2000">
-                <a:solidFill>
-                  <a:srgbClr val="334155"/>
-                </a:solidFill>
-              </a:rPr>
-              <a:t>•  Publicar corpus derivado en Zenodo</a:t>
+              <a:t>•  Todo en GitHub: git clone + notebook = reproducible</a:t>
             </a:r>
           </a:p>
         </p:txBody>
@@ -5100,6 +5095,183 @@
 </file>
 
 <file path=ppt/slides/slide20.xml><?xml version="1.0" encoding="utf-8"?>
+<p:sld xmlns:a="http://schemas.openxmlformats.org/drawingml/2006/main" xmlns:p="http://schemas.openxmlformats.org/presentationml/2006/main" xmlns:r="http://schemas.openxmlformats.org/officeDocument/2006/relationships">
+  <p:cSld>
+    <p:spTree>
+      <p:nvGrpSpPr>
+        <p:cNvPr id="1" name=""/>
+        <p:cNvGrpSpPr/>
+        <p:nvPr/>
+      </p:nvGrpSpPr>
+      <p:grpSpPr/>
+      <p:sp>
+        <p:nvSpPr>
+          <p:cNvPr id="2" name="TextBox 1"/>
+          <p:cNvSpPr txBox="1"/>
+          <p:nvPr/>
+        </p:nvSpPr>
+        <p:spPr>
+          <a:xfrm>
+            <a:off x="457200" y="274320"/>
+            <a:ext cx="11277295" cy="822960"/>
+          </a:xfrm>
+          <a:prstGeom prst="rect">
+            <a:avLst/>
+          </a:prstGeom>
+          <a:noFill/>
+        </p:spPr>
+        <p:txBody>
+          <a:bodyPr wrap="none">
+            <a:spAutoFit/>
+          </a:bodyPr>
+          <a:lstStyle/>
+          <a:p>
+            <a:r>
+              <a:rPr sz="3200" b="1">
+                <a:solidFill>
+                  <a:srgbClr val="0F172A"/>
+                </a:solidFill>
+              </a:rPr>
+              <a:t>18 · Próximos pasos</a:t>
+            </a:r>
+          </a:p>
+        </p:txBody>
+      </p:sp>
+      <p:sp>
+        <p:nvSpPr>
+          <p:cNvPr id="3" name="TextBox 2"/>
+          <p:cNvSpPr txBox="1"/>
+          <p:nvPr/>
+        </p:nvSpPr>
+        <p:spPr>
+          <a:xfrm>
+            <a:off x="457200" y="1371600"/>
+            <a:ext cx="10972800" cy="5029200"/>
+          </a:xfrm>
+          <a:prstGeom prst="rect">
+            <a:avLst/>
+          </a:prstGeom>
+          <a:noFill/>
+        </p:spPr>
+        <p:txBody>
+          <a:bodyPr wrap="square">
+            <a:spAutoFit/>
+          </a:bodyPr>
+          <a:lstStyle/>
+          <a:p>
+            <a:pPr>
+              <a:spcBef>
+                <a:spcPts val="800"/>
+              </a:spcBef>
+            </a:pPr>
+            <a:r>
+              <a:rPr sz="2000">
+                <a:solidFill>
+                  <a:srgbClr val="334155"/>
+                </a:solidFill>
+              </a:rPr>
+              <a:t>•  Re-entrenar SegNT con guardado a Drive cada época</a:t>
+            </a:r>
+          </a:p>
+          <a:p>
+            <a:pPr>
+              <a:spcBef>
+                <a:spcPts val="800"/>
+              </a:spcBef>
+            </a:pPr>
+          </a:p>
+          <a:p>
+            <a:pPr>
+              <a:spcBef>
+                <a:spcPts val="800"/>
+              </a:spcBef>
+            </a:pPr>
+            <a:r>
+              <a:rPr sz="2000" b="1">
+                <a:solidFill>
+                  <a:srgbClr val="334155"/>
+                </a:solidFill>
+              </a:rPr>
+              <a:t>•  Escalar dataset piloto: 50 000 → 200 000 ventanas</a:t>
+            </a:r>
+          </a:p>
+          <a:p>
+            <a:pPr>
+              <a:spcBef>
+                <a:spcPts val="800"/>
+              </a:spcBef>
+            </a:pPr>
+          </a:p>
+          <a:p>
+            <a:pPr>
+              <a:spcBef>
+                <a:spcPts val="800"/>
+              </a:spcBef>
+            </a:pPr>
+            <a:r>
+              <a:rPr sz="2000">
+                <a:solidFill>
+                  <a:srgbClr val="334155"/>
+                </a:solidFill>
+              </a:rPr>
+              <a:t>•  Re-entrenar Filter con etiquetas de intactness</a:t>
+            </a:r>
+          </a:p>
+          <a:p>
+            <a:pPr>
+              <a:spcBef>
+                <a:spcPts val="800"/>
+              </a:spcBef>
+            </a:pPr>
+          </a:p>
+          <a:p>
+            <a:pPr>
+              <a:spcBef>
+                <a:spcPts val="800"/>
+              </a:spcBef>
+            </a:pPr>
+            <a:r>
+              <a:rPr sz="2000">
+                <a:solidFill>
+                  <a:srgbClr val="334155"/>
+                </a:solidFill>
+              </a:rPr>
+              <a:t>•  Evaluar sobre maíz (2 Gb) y trigo (14 Gb)</a:t>
+            </a:r>
+          </a:p>
+          <a:p>
+            <a:pPr>
+              <a:spcBef>
+                <a:spcPts val="800"/>
+              </a:spcBef>
+            </a:pPr>
+          </a:p>
+          <a:p>
+            <a:pPr>
+              <a:spcBef>
+                <a:spcPts val="800"/>
+              </a:spcBef>
+            </a:pPr>
+            <a:r>
+              <a:rPr sz="2000">
+                <a:solidFill>
+                  <a:srgbClr val="334155"/>
+                </a:solidFill>
+              </a:rPr>
+              <a:t>•  Publicar corpus derivado en Zenodo</a:t>
+            </a:r>
+          </a:p>
+        </p:txBody>
+      </p:sp>
+    </p:spTree>
+  </p:cSld>
+  <p:clrMapOvr>
+    <a:masterClrMapping/>
+  </p:clrMapOvr>
+</p:sld>
+</file>
+
+<file path=ppt/slides/slide21.xml><?xml version="1.0" encoding="utf-8"?>
 <p:sld xmlns:a="http://schemas.openxmlformats.org/drawingml/2006/main" xmlns:p="http://schemas.openxmlformats.org/presentationml/2006/main" xmlns:r="http://schemas.openxmlformats.org/officeDocument/2006/relationships">
   <p:cSld>
     <p:spTree>

</xml_diff>